<commit_message>
Chinese poster: static Noto Sans SC so the PDF keeps its weights
The installed Noto Sans SC is a variable font whose default instance is
Thin, and PowerPoint's PDF export embeds that default for every
weight: regular, bold and the Black headings all came out thin in
poster_amd_zh.pdf although the PNG render looked right. The poster
now uses static instances of the same font ("Noto Sans SC Static"
regular/bold and "Noto Sans SC Static Black", cut with the fontTools
instancer and installed per user). The vertical headings are set one
character per line at one em, since vertical text in these fonts
overlapped in the PDF. Also fixes the unterminated docstring in
make_zh.py.

Co-Authored-By: Claude Opus 5.5 <noreply@anthropic.com>
</commit_message>
<xml_diff>
--- a/report/poster/poster_amd_zh.pptx
+++ b/report/poster/poster_amd_zh.pptx
@@ -1073,7 +1073,7 @@
                     <a:solidFill>
                       <a:srgbClr val="1F2933"/>
                     </a:solidFill>
-                    <a:ea typeface="Noto Sans SC"/>
+                    <a:ea typeface="Noto Sans SC Static"/>
                   </a:rPr>
                   <a:t>空口SNR (dB)</a:t>
                 </a:r>
@@ -1103,7 +1103,7 @@
                 <a:solidFill>
                   <a:srgbClr val="52606D"/>
                 </a:solidFill>
-                <a:ea typeface="Noto Sans SC"/>
+                <a:ea typeface="Noto Sans SC Static"/>
               </a:defRPr>
             </a:pPr>
           </a:p>
@@ -1142,7 +1142,7 @@
                     <a:solidFill>
                       <a:srgbClr val="1F2933"/>
                     </a:solidFill>
-                    <a:ea typeface="Noto Sans SC"/>
+                    <a:ea typeface="Noto Sans SC Static"/>
                   </a:rPr>
                   <a:t>PSNR (dB)</a:t>
                 </a:r>
@@ -1172,7 +1172,7 @@
                 <a:solidFill>
                   <a:srgbClr val="52606D"/>
                 </a:solidFill>
-                <a:ea typeface="Noto Sans SC"/>
+                <a:ea typeface="Noto Sans SC Static"/>
               </a:defRPr>
             </a:pPr>
           </a:p>
@@ -1199,11 +1199,11 @@
       <a:pPr>
         <a:defRPr sz="800">
           <a:latin typeface="Calibri"/>
-          <a:ea typeface="Noto Sans SC"/>
+          <a:ea typeface="Noto Sans SC Static"/>
         </a:defRPr>
       </a:pPr>
       <a:endParaRPr lang="en-US">
-        <a:ea typeface="Noto Sans SC"/>
+        <a:ea typeface="Noto Sans SC Static"/>
       </a:endParaRPr>
     </a:p>
   </c:txPr>
@@ -18513,7 +18513,7 @@
                   <a:schemeClr val="bg1"/>
                 </a:solidFill>
                 <a:latin typeface="Aharoni" panose="020F0502020204030204" pitchFamily="34" charset="0"/>
-                <a:ea typeface="Noto Sans SC Black"/>
+                <a:ea typeface="Noto Sans SC Static Black"/>
                 <a:cs typeface="Aharoni" panose="020F0502020204030204" pitchFamily="34" charset="0"/>
               </a:rPr>
               <a:t>作品简介</a:t>
@@ -18565,7 +18565,7 @@
               <a:buNone/>
               <a:tabLst/>
               <a:defRPr>
-                <a:ea typeface="Noto Sans SC"/>
+                <a:ea typeface="Noto Sans SC Static"/>
               </a:defRPr>
             </a:pPr>
             <a:r>
@@ -18604,7 +18604,7 @@
               <a:buNone/>
               <a:tabLst/>
               <a:defRPr>
-                <a:ea typeface="Noto Sans SC"/>
+                <a:ea typeface="Noto Sans SC Static"/>
               </a:defRPr>
             </a:pPr>
             <a:r>
@@ -18670,7 +18670,7 @@
                   <a:schemeClr val="tx1"/>
                 </a:solidFill>
                 <a:latin typeface="+mj-lt"/>
-                <a:ea typeface="Noto Sans SC"/>
+                <a:ea typeface="Noto Sans SC Static"/>
                 <a:cs typeface="+mj-cs"/>
               </a:defRPr>
             </a:lvl1pPr>
@@ -18692,7 +18692,7 @@
               <a:buNone/>
               <a:tabLst/>
               <a:defRPr>
-                <a:ea typeface="Noto Sans SC"/>
+                <a:ea typeface="Noto Sans SC Static"/>
               </a:defRPr>
             </a:pPr>
             <a:endParaRPr kumimoji="0" lang="en-US" sz="700" b="1" i="0" u="none" strike="noStrike" kern="1200" cap="none" spc="0" normalizeH="0" baseline="0" noProof="0" dirty="0">
@@ -18706,7 +18706,7 @@
               <a:uLnTx/>
               <a:uFillTx/>
               <a:latin typeface="Calibri" panose="020F0502020204030204"/>
-              <a:ea typeface="Noto Sans SC"/>
+              <a:ea typeface="Noto Sans SC Static"/>
               <a:cs typeface="+mj-cs"/>
             </a:endParaRPr>
           </a:p>
@@ -18873,7 +18873,7 @@
               <a:buNone/>
               <a:tabLst/>
               <a:defRPr>
-                <a:ea typeface="Noto Sans SC"/>
+                <a:ea typeface="Noto Sans SC Static"/>
               </a:defRPr>
             </a:pPr>
             <a:r>
@@ -18925,7 +18925,7 @@
           <a:lstStyle>
             <a:defPPr>
               <a:defRPr lang="en-US">
-                <a:ea typeface="Noto Sans SC"/>
+                <a:ea typeface="Noto Sans SC Static"/>
               </a:defRPr>
             </a:defPPr>
             <a:lvl1pPr indent="0">
@@ -18953,7 +18953,7 @@
               <a:buFont typeface="Arial" panose="020B0604020202020204" pitchFamily="34" charset="0"/>
               <a:buChar char="•"/>
               <a:defRPr sz="2400">
-                <a:ea typeface="Noto Sans SC"/>
+                <a:ea typeface="Noto Sans SC Static"/>
               </a:defRPr>
             </a:lvl2pPr>
             <a:lvl3pPr marL="1143000" indent="-228600">
@@ -18966,7 +18966,7 @@
               <a:buFont typeface="Arial" panose="020B0604020202020204" pitchFamily="34" charset="0"/>
               <a:buChar char="•"/>
               <a:defRPr sz="2000">
-                <a:ea typeface="Noto Sans SC"/>
+                <a:ea typeface="Noto Sans SC Static"/>
               </a:defRPr>
             </a:lvl3pPr>
             <a:lvl4pPr marL="1600200" indent="-228600">
@@ -19047,7 +19047,7 @@
               <a:buNone/>
               <a:tabLst/>
               <a:defRPr>
-                <a:ea typeface="Noto Sans SC"/>
+                <a:ea typeface="Noto Sans SC Static"/>
               </a:defRPr>
             </a:pPr>
             <a:r>
@@ -19085,7 +19085,7 @@
               <a:buNone/>
               <a:tabLst/>
               <a:defRPr>
-                <a:ea typeface="Noto Sans SC"/>
+                <a:ea typeface="Noto Sans SC Static"/>
               </a:defRPr>
             </a:pPr>
             <a:r>
@@ -19152,7 +19152,7 @@
               <a:buNone/>
               <a:tabLst/>
               <a:defRPr>
-                <a:ea typeface="Noto Sans SC"/>
+                <a:ea typeface="Noto Sans SC Static"/>
               </a:defRPr>
             </a:pPr>
             <a:r>
@@ -19191,7 +19191,7 @@
               <a:buNone/>
               <a:tabLst/>
               <a:defRPr>
-                <a:ea typeface="Noto Sans SC"/>
+                <a:ea typeface="Noto Sans SC Static"/>
               </a:defRPr>
             </a:pPr>
             <a:r>
@@ -19257,7 +19257,7 @@
                   <a:schemeClr val="tx1"/>
                 </a:solidFill>
                 <a:latin typeface="+mj-lt"/>
-                <a:ea typeface="Noto Sans SC"/>
+                <a:ea typeface="Noto Sans SC Static"/>
                 <a:cs typeface="+mj-cs"/>
               </a:defRPr>
             </a:lvl1pPr>
@@ -19279,7 +19279,7 @@
               <a:buNone/>
               <a:tabLst/>
               <a:defRPr>
-                <a:ea typeface="Noto Sans SC"/>
+                <a:ea typeface="Noto Sans SC Static"/>
               </a:defRPr>
             </a:pPr>
             <a:endParaRPr kumimoji="0" lang="en-US" sz="700" b="1" i="0" u="none" strike="noStrike" kern="1200" cap="none" spc="0" normalizeH="0" baseline="0" noProof="0" dirty="0">
@@ -19293,7 +19293,7 @@
               <a:uLnTx/>
               <a:uFillTx/>
               <a:latin typeface="Calibri" panose="020F0502020204030204"/>
-              <a:ea typeface="Noto Sans SC"/>
+              <a:ea typeface="Noto Sans SC Static"/>
               <a:cs typeface="+mj-cs"/>
             </a:endParaRPr>
           </a:p>
@@ -19337,8 +19337,8 @@
         </p:nvSpPr>
         <p:spPr>
           <a:xfrm>
-            <a:off x="7733160" y="2310130"/>
-            <a:ext cx="411468" cy="1117600"/>
+            <a:off x="7733160" y="2090674"/>
+            <a:ext cx="411468" cy="1556512"/>
           </a:xfrm>
           <a:prstGeom prst="rect">
             <a:avLst/>
@@ -19346,20 +19346,84 @@
           <a:noFill/>
         </p:spPr>
         <p:txBody>
-          <a:bodyPr wrap="square" anchor="ctr" lIns="0" rIns="0" tIns="0" bIns="0" vert="eaVert">
+          <a:bodyPr wrap="square" anchor="ctr" lIns="0" rIns="0" tIns="0" bIns="0">
             <a:spAutoFit/>
           </a:bodyPr>
           <a:lstStyle/>
           <a:p>
-            <a:pPr algn="ctr"/>
+            <a:pPr algn="ctr">
+              <a:lnSpc>
+                <a:spcPts val="2200"/>
+              </a:lnSpc>
+              <a:spcBef>
+                <a:spcPts val="0"/>
+              </a:spcBef>
+            </a:pPr>
             <a:r>
               <a:rPr sz="2200" b="1" lang="zh-CN" altLang="en-US">
                 <a:solidFill>
                   <a:srgbClr val="FFFFFF"/>
                 </a:solidFill>
-                <a:ea typeface="Noto Sans SC Black"/>
+                <a:ea typeface="Noto Sans SC Static"/>
               </a:rPr>
-              <a:t>创新设计</a:t>
+              <a:t>创</a:t>
+            </a:r>
+          </a:p>
+          <a:p>
+            <a:pPr algn="ctr">
+              <a:lnSpc>
+                <a:spcPts val="2200"/>
+              </a:lnSpc>
+              <a:spcBef>
+                <a:spcPts val="0"/>
+              </a:spcBef>
+            </a:pPr>
+            <a:r>
+              <a:rPr sz="2200" b="1" lang="zh-CN" altLang="en-US">
+                <a:solidFill>
+                  <a:srgbClr val="FFFFFF"/>
+                </a:solidFill>
+                <a:ea typeface="Noto Sans SC Static"/>
+              </a:rPr>
+              <a:t>新</a:t>
+            </a:r>
+          </a:p>
+          <a:p>
+            <a:pPr algn="ctr">
+              <a:lnSpc>
+                <a:spcPts val="2200"/>
+              </a:lnSpc>
+              <a:spcBef>
+                <a:spcPts val="0"/>
+              </a:spcBef>
+            </a:pPr>
+            <a:r>
+              <a:rPr sz="2200" b="1" lang="zh-CN" altLang="en-US">
+                <a:solidFill>
+                  <a:srgbClr val="FFFFFF"/>
+                </a:solidFill>
+                <a:ea typeface="Noto Sans SC Static"/>
+              </a:rPr>
+              <a:t>设</a:t>
+            </a:r>
+          </a:p>
+          <a:p>
+            <a:pPr algn="ctr">
+              <a:lnSpc>
+                <a:spcPts val="2200"/>
+              </a:lnSpc>
+              <a:spcBef>
+                <a:spcPts val="0"/>
+              </a:spcBef>
+            </a:pPr>
+            <a:r>
+              <a:rPr sz="2200" b="1" lang="zh-CN" altLang="en-US">
+                <a:solidFill>
+                  <a:srgbClr val="FFFFFF"/>
+                </a:solidFill>
+                <a:ea typeface="Noto Sans SC Static"/>
+              </a:rPr>
+              <a:t>计</a:t>
             </a:r>
           </a:p>
         </p:txBody>
@@ -19372,8 +19436,8 @@
         </p:nvSpPr>
         <p:spPr>
           <a:xfrm>
-            <a:off x="8507018" y="2271592"/>
-            <a:ext cx="411468" cy="1117600"/>
+            <a:off x="8507018" y="2052136"/>
+            <a:ext cx="411468" cy="1556512"/>
           </a:xfrm>
           <a:prstGeom prst="rect">
             <a:avLst/>
@@ -19381,20 +19445,84 @@
           <a:noFill/>
         </p:spPr>
         <p:txBody>
-          <a:bodyPr wrap="square" anchor="ctr" lIns="0" rIns="0" tIns="0" bIns="0" vert="eaVert">
+          <a:bodyPr wrap="square" anchor="ctr" lIns="0" rIns="0" tIns="0" bIns="0">
             <a:spAutoFit/>
           </a:bodyPr>
           <a:lstStyle/>
           <a:p>
-            <a:pPr algn="ctr"/>
+            <a:pPr algn="ctr">
+              <a:lnSpc>
+                <a:spcPts val="2200"/>
+              </a:lnSpc>
+              <a:spcBef>
+                <a:spcPts val="0"/>
+              </a:spcBef>
+            </a:pPr>
             <a:r>
               <a:rPr sz="2200" b="1" lang="zh-CN" altLang="en-US">
                 <a:solidFill>
                   <a:srgbClr val="FFFFFF"/>
                 </a:solidFill>
-                <a:ea typeface="Noto Sans SC Black"/>
+                <a:ea typeface="Noto Sans SC Static"/>
               </a:rPr>
-              <a:t>测试结果</a:t>
+              <a:t>测</a:t>
+            </a:r>
+          </a:p>
+          <a:p>
+            <a:pPr algn="ctr">
+              <a:lnSpc>
+                <a:spcPts val="2200"/>
+              </a:lnSpc>
+              <a:spcBef>
+                <a:spcPts val="0"/>
+              </a:spcBef>
+            </a:pPr>
+            <a:r>
+              <a:rPr sz="2200" b="1" lang="zh-CN" altLang="en-US">
+                <a:solidFill>
+                  <a:srgbClr val="FFFFFF"/>
+                </a:solidFill>
+                <a:ea typeface="Noto Sans SC Static"/>
+              </a:rPr>
+              <a:t>试</a:t>
+            </a:r>
+          </a:p>
+          <a:p>
+            <a:pPr algn="ctr">
+              <a:lnSpc>
+                <a:spcPts val="2200"/>
+              </a:lnSpc>
+              <a:spcBef>
+                <a:spcPts val="0"/>
+              </a:spcBef>
+            </a:pPr>
+            <a:r>
+              <a:rPr sz="2200" b="1" lang="zh-CN" altLang="en-US">
+                <a:solidFill>
+                  <a:srgbClr val="FFFFFF"/>
+                </a:solidFill>
+                <a:ea typeface="Noto Sans SC Static"/>
+              </a:rPr>
+              <a:t>结</a:t>
+            </a:r>
+          </a:p>
+          <a:p>
+            <a:pPr algn="ctr">
+              <a:lnSpc>
+                <a:spcPts val="2200"/>
+              </a:lnSpc>
+              <a:spcBef>
+                <a:spcPts val="0"/>
+              </a:spcBef>
+            </a:pPr>
+            <a:r>
+              <a:rPr sz="2200" b="1" lang="zh-CN" altLang="en-US">
+                <a:solidFill>
+                  <a:srgbClr val="FFFFFF"/>
+                </a:solidFill>
+                <a:ea typeface="Noto Sans SC Static"/>
+              </a:rPr>
+              <a:t>果</a:t>
             </a:r>
           </a:p>
         </p:txBody>
@@ -19476,7 +19604,7 @@
                   <a:srgbClr val="000000"/>
                 </a:solidFill>
                 <a:latin typeface="Calibri"/>
-                <a:ea typeface="Noto Sans SC"/>
+                <a:ea typeface="Noto Sans SC Static"/>
               </a:rPr>
               <a:t>无人机、机器人和远程摄像头的实时视频要经过信噪比时刻变化的无线链路。</a:t>
             </a:r>
@@ -19486,7 +19614,7 @@
                   <a:srgbClr val="000000"/>
                 </a:solidFill>
                 <a:latin typeface="Calibri"/>
-                <a:ea typeface="Noto Sans SC"/>
+                <a:ea typeface="Noto Sans SC Static"/>
               </a:rPr>
               <a:t>分离信源信道编码（SSCC）</a:t>
             </a:r>
@@ -19496,7 +19624,7 @@
                   <a:srgbClr val="000000"/>
                 </a:solidFill>
                 <a:latin typeface="Calibri"/>
-                <a:ea typeface="Noto Sans SC"/>
+                <a:ea typeface="Noto Sans SC Static"/>
               </a:rPr>
               <a:t>先用JPEG压缩、再加信道编码：信噪比低于纠错门限时，比特错误沿变长码扩散，整幅图像无法解码（</a:t>
             </a:r>
@@ -19506,7 +19634,7 @@
                   <a:srgbClr val="000000"/>
                 </a:solidFill>
                 <a:latin typeface="Calibri"/>
-                <a:ea typeface="Noto Sans SC"/>
+                <a:ea typeface="Noto Sans SC Static"/>
               </a:rPr>
               <a:t>悬崖效应</a:t>
             </a:r>
@@ -19516,7 +19644,7 @@
                   <a:srgbClr val="000000"/>
                 </a:solidFill>
                 <a:latin typeface="Calibri"/>
-                <a:ea typeface="Noto Sans SC"/>
+                <a:ea typeface="Noto Sans SC Static"/>
               </a:rPr>
               <a:t>）；高于门限后画质也不再提升。</a:t>
             </a:r>
@@ -19552,7 +19680,7 @@
                   <a:srgbClr val="000000"/>
                 </a:solidFill>
                 <a:latin typeface="Calibri"/>
-                <a:ea typeface="Noto Sans SC"/>
+                <a:ea typeface="Noto Sans SC Static"/>
               </a:rPr>
               <a:t>典型应用场景</a:t>
             </a:r>
@@ -19610,7 +19738,7 @@
                   <a:srgbClr val="1F2933"/>
                 </a:solidFill>
                 <a:latin typeface="Calibri"/>
-                <a:ea typeface="Noto Sans SC"/>
+                <a:ea typeface="Noto Sans SC Static"/>
               </a:rPr>
               <a:t>摄像头</a:t>
             </a:r>
@@ -19623,7 +19751,7 @@
                   <a:srgbClr val="52606D"/>
                 </a:solidFill>
                 <a:latin typeface="Calibri"/>
-                <a:ea typeface="Noto Sans SC"/>
+                <a:ea typeface="Noto Sans SC Static"/>
               </a:rPr>
               <a:t>无人机等</a:t>
             </a:r>
@@ -19717,7 +19845,7 @@
                   <a:srgbClr val="1F2933"/>
                 </a:solidFill>
                 <a:latin typeface="Calibri"/>
-                <a:ea typeface="Noto Sans SC"/>
+                <a:ea typeface="Noto Sans SC Static"/>
               </a:rPr>
               <a:t>编码器</a:t>
             </a:r>
@@ -19730,7 +19858,7 @@
                   <a:srgbClr val="52606D"/>
                 </a:solidFill>
                 <a:latin typeface="Calibri"/>
-                <a:ea typeface="Noto Sans SC"/>
+                <a:ea typeface="Noto Sans SC Static"/>
               </a:rPr>
               <a:t>FPGA，发端</a:t>
             </a:r>
@@ -19824,7 +19952,7 @@
                   <a:srgbClr val="1F2933"/>
                 </a:solidFill>
                 <a:latin typeface="Calibri"/>
-                <a:ea typeface="Noto Sans SC"/>
+                <a:ea typeface="Noto Sans SC Static"/>
               </a:rPr>
               <a:t>无线信道</a:t>
             </a:r>
@@ -19837,7 +19965,7 @@
                   <a:srgbClr val="52606D"/>
                 </a:solidFill>
                 <a:latin typeface="Calibri"/>
-                <a:ea typeface="Noto Sans SC"/>
+                <a:ea typeface="Noto Sans SC Static"/>
               </a:rPr>
               <a:t>噪声、衰落</a:t>
             </a:r>
@@ -19931,7 +20059,7 @@
                   <a:srgbClr val="1F2933"/>
                 </a:solidFill>
                 <a:latin typeface="Calibri"/>
-                <a:ea typeface="Noto Sans SC"/>
+                <a:ea typeface="Noto Sans SC Static"/>
               </a:rPr>
               <a:t>解码器</a:t>
             </a:r>
@@ -19944,7 +20072,7 @@
                   <a:srgbClr val="52606D"/>
                 </a:solidFill>
                 <a:latin typeface="Calibri"/>
-                <a:ea typeface="Noto Sans SC"/>
+                <a:ea typeface="Noto Sans SC Static"/>
               </a:rPr>
               <a:t>FPGA，收端</a:t>
             </a:r>
@@ -20038,7 +20166,7 @@
                   <a:srgbClr val="1F2933"/>
                 </a:solidFill>
                 <a:latin typeface="Calibri"/>
-                <a:ea typeface="Noto Sans SC"/>
+                <a:ea typeface="Noto Sans SC Static"/>
               </a:rPr>
               <a:t>显示</a:t>
             </a:r>
@@ -20051,7 +20179,7 @@
                   <a:srgbClr val="52606D"/>
                 </a:solidFill>
                 <a:latin typeface="Calibri"/>
-                <a:ea typeface="Noto Sans SC"/>
+                <a:ea typeface="Noto Sans SC Static"/>
               </a:rPr>
               <a:t>实时画面</a:t>
             </a:r>
@@ -20087,7 +20215,7 @@
                   <a:srgbClr val="000000"/>
                 </a:solidFill>
                 <a:latin typeface="Calibri"/>
-                <a:ea typeface="Noto Sans SC"/>
+                <a:ea typeface="Noto Sans SC Static"/>
               </a:rPr>
               <a:t>深度联合信源信道编码（DeepJSCC）</a:t>
             </a:r>
@@ -20097,7 +20225,7 @@
                   <a:srgbClr val="000000"/>
                 </a:solidFill>
                 <a:latin typeface="Calibri"/>
-                <a:ea typeface="Noto Sans SC"/>
+                <a:ea typeface="Noto Sans SC Static"/>
               </a:rPr>
               <a:t>用一对卷积神经网络把像素直接映射为信道符号，画质随信噪比平缓变化。</a:t>
             </a:r>
@@ -20107,7 +20235,7 @@
                   <a:srgbClr val="000000"/>
                 </a:solidFill>
                 <a:latin typeface="Calibri"/>
-                <a:ea typeface="Noto Sans SC"/>
+                <a:ea typeface="Noto Sans SC Static"/>
               </a:rPr>
               <a:t>DeepJSCC-Q</a:t>
             </a:r>
@@ -20117,7 +20245,7 @@
                   <a:srgbClr val="000000"/>
                 </a:solidFill>
                 <a:latin typeface="Calibri"/>
-                <a:ea typeface="Noto Sans SC"/>
+                <a:ea typeface="Noto Sans SC Static"/>
               </a:rPr>
               <a:t>（Tung等，JSAIT 2022）进一步把符号约束到QAM星座上，可接入标准数字物理层；但它计算量大，接收端还必须把未经判决的软符号送入解码器。</a:t>
             </a:r>
@@ -20134,7 +20262,7 @@
                   <a:srgbClr val="000000"/>
                 </a:solidFill>
                 <a:latin typeface="Calibri"/>
-                <a:ea typeface="Noto Sans SC"/>
+                <a:ea typeface="Noto Sans SC Static"/>
               </a:rPr>
               <a:t>GlideLink</a:t>
             </a:r>
@@ -20144,7 +20272,7 @@
                   <a:srgbClr val="000000"/>
                 </a:solidFill>
                 <a:latin typeface="Calibri"/>
-                <a:ea typeface="Noto Sans SC"/>
+                <a:ea typeface="Noto Sans SC Static"/>
               </a:rPr>
               <a:t>用两块AMD Zynq UltraScale+ MPSoC开发板（PYNQ-ZU）和AD9361射频子卡搭建了完整的实时链路：DeepJSCC-Q编码器、解码器和类802.11a OFDM物理层全部在PL中实现，</a:t>
             </a:r>
@@ -20154,7 +20282,7 @@
                   <a:srgbClr val="000000"/>
                 </a:solidFill>
                 <a:latin typeface="Calibri"/>
-                <a:ea typeface="Noto Sans SC"/>
+                <a:ea typeface="Noto Sans SC Static"/>
               </a:rPr>
               <a:t>经空口以30 fps传输256×256彩色图像</a:t>
             </a:r>
@@ -20164,7 +20292,7 @@
                   <a:srgbClr val="000000"/>
                 </a:solidFill>
                 <a:latin typeface="Calibri"/>
-                <a:ea typeface="Noto Sans SC"/>
+                <a:ea typeface="Noto Sans SC Static"/>
               </a:rPr>
               <a:t>；PS负责取图和射频配置，并在触摸屏上实时显示链路状态。</a:t>
             </a:r>
@@ -20181,7 +20309,7 @@
                   <a:srgbClr val="000000"/>
                 </a:solidFill>
                 <a:latin typeface="Calibri"/>
-                <a:ea typeface="Noto Sans SC"/>
+                <a:ea typeface="Noto Sans SC Static"/>
               </a:rPr>
               <a:t>关键技术问题：</a:t>
             </a:r>
@@ -20191,7 +20319,7 @@
                   <a:srgbClr val="000000"/>
                 </a:solidFill>
                 <a:latin typeface="Calibri"/>
-                <a:ea typeface="Noto Sans SC"/>
+                <a:ea typeface="Noto Sans SC Static"/>
               </a:rPr>
               <a:t>每帧1.15 GMAC的神经网络编解码器要以30 fps放进一片FPGA，且权重全部片上；683个符号的长OFDM帧要同步、跟踪到足以直接解码软符号的精度；还要在同一物理层上与JPEG + LDPC做公平的空口对比。</a:t>
             </a:r>
@@ -20275,7 +20403,7 @@
                   <a:srgbClr val="000000"/>
                 </a:solidFill>
                 <a:latin typeface="Calibri"/>
-                <a:ea typeface="Noto Sans SC"/>
+                <a:ea typeface="Noto Sans SC Static"/>
               </a:rPr>
               <a:t>发端板</a:t>
             </a:r>
@@ -20285,7 +20413,7 @@
                   <a:srgbClr val="52606D"/>
                 </a:solidFill>
                 <a:latin typeface="Calibri"/>
-                <a:ea typeface="Noto Sans SC"/>
+                <a:ea typeface="Noto Sans SC Static"/>
               </a:rPr>
               <a:t>  PYNQ-ZU (xczu5eg)</a:t>
             </a:r>
@@ -20343,7 +20471,7 @@
                   <a:srgbClr val="1F2933"/>
                 </a:solidFill>
                 <a:latin typeface="Calibri"/>
-                <a:ea typeface="Noto Sans SC"/>
+                <a:ea typeface="Noto Sans SC Static"/>
               </a:rPr>
               <a:t>PS</a:t>
             </a:r>
@@ -20356,7 +20484,7 @@
                   <a:srgbClr val="52606D"/>
                 </a:solidFill>
                 <a:latin typeface="Calibri"/>
-                <a:ea typeface="Noto Sans SC"/>
+                <a:ea typeface="Noto Sans SC Static"/>
               </a:rPr>
               <a:t>4×A53，Linux：取图、射频配置</a:t>
             </a:r>
@@ -20414,7 +20542,7 @@
                   <a:srgbClr val="1F2933"/>
                 </a:solidFill>
                 <a:latin typeface="Calibri"/>
-                <a:ea typeface="Noto Sans SC"/>
+                <a:ea typeface="Noto Sans SC Static"/>
               </a:rPr>
               <a:t>PL</a:t>
             </a:r>
@@ -20427,7 +20555,7 @@
                   <a:srgbClr val="52606D"/>
                 </a:solidFill>
                 <a:latin typeface="Calibri"/>
-                <a:ea typeface="Noto Sans SC"/>
+                <a:ea typeface="Noto Sans SC Static"/>
               </a:rPr>
               <a:t>CNN编码、OFDM发射、LDPC编码</a:t>
             </a:r>
@@ -20485,7 +20613,7 @@
                   <a:srgbClr val="1F2933"/>
                 </a:solidFill>
                 <a:latin typeface="Calibri"/>
-                <a:ea typeface="Noto Sans SC"/>
+                <a:ea typeface="Noto Sans SC Static"/>
               </a:rPr>
               <a:t>摄像头</a:t>
             </a:r>
@@ -20557,7 +20685,7 @@
                   <a:srgbClr val="52606D"/>
                 </a:solidFill>
                 <a:latin typeface="Calibri"/>
-                <a:ea typeface="Noto Sans SC"/>
+                <a:ea typeface="Noto Sans SC Static"/>
               </a:rPr>
               <a:t>USB</a:t>
             </a:r>
@@ -20615,7 +20743,7 @@
                   <a:srgbClr val="1F2933"/>
                 </a:solidFill>
                 <a:latin typeface="Calibri"/>
-                <a:ea typeface="Noto Sans SC"/>
+                <a:ea typeface="Noto Sans SC Static"/>
               </a:rPr>
               <a:t>AD9361</a:t>
             </a:r>
@@ -20628,7 +20756,7 @@
                   <a:srgbClr val="52606D"/>
                 </a:solidFill>
                 <a:latin typeface="Calibri"/>
-                <a:ea typeface="Noto Sans SC"/>
+                <a:ea typeface="Noto Sans SC Static"/>
               </a:rPr>
               <a:t>射频子卡</a:t>
             </a:r>
@@ -20737,7 +20865,7 @@
                   <a:srgbClr val="52606D"/>
                 </a:solidFill>
                 <a:latin typeface="Calibri"/>
-                <a:ea typeface="Noto Sans SC"/>
+                <a:ea typeface="Noto Sans SC Static"/>
               </a:rPr>
               <a:t>AXI</a:t>
             </a:r>
@@ -20773,7 +20901,7 @@
                   <a:srgbClr val="52606D"/>
                 </a:solidFill>
                 <a:latin typeface="Calibri"/>
-                <a:ea typeface="Noto Sans SC"/>
+                <a:ea typeface="Noto Sans SC Static"/>
               </a:rPr>
               <a:t>FMC</a:t>
             </a:r>
@@ -20997,7 +21125,7 @@
                   <a:srgbClr val="000000"/>
                 </a:solidFill>
                 <a:latin typeface="Calibri"/>
-                <a:ea typeface="Noto Sans SC"/>
+                <a:ea typeface="Noto Sans SC Static"/>
               </a:rPr>
               <a:t>收端板</a:t>
             </a:r>
@@ -21007,7 +21135,7 @@
                   <a:srgbClr val="52606D"/>
                 </a:solidFill>
                 <a:latin typeface="Calibri"/>
-                <a:ea typeface="Noto Sans SC"/>
+                <a:ea typeface="Noto Sans SC Static"/>
               </a:rPr>
               <a:t>  PYNQ-ZU (xczu5eg)</a:t>
             </a:r>
@@ -21065,7 +21193,7 @@
                   <a:srgbClr val="1F2933"/>
                 </a:solidFill>
                 <a:latin typeface="Calibri"/>
-                <a:ea typeface="Noto Sans SC"/>
+                <a:ea typeface="Noto Sans SC Static"/>
               </a:rPr>
               <a:t>PS</a:t>
             </a:r>
@@ -21078,7 +21206,7 @@
                   <a:srgbClr val="52606D"/>
                 </a:solidFill>
                 <a:latin typeface="Calibri"/>
-                <a:ea typeface="Noto Sans SC"/>
+                <a:ea typeface="Noto Sans SC Static"/>
               </a:rPr>
               <a:t>A53 + Mali-400：界面、网页</a:t>
             </a:r>
@@ -21136,7 +21264,7 @@
                   <a:srgbClr val="1F2933"/>
                 </a:solidFill>
                 <a:latin typeface="Calibri"/>
-                <a:ea typeface="Noto Sans SC"/>
+                <a:ea typeface="Noto Sans SC Static"/>
               </a:rPr>
               <a:t>PL</a:t>
             </a:r>
@@ -21149,7 +21277,7 @@
                   <a:srgbClr val="52606D"/>
                 </a:solidFill>
                 <a:latin typeface="Calibri"/>
-                <a:ea typeface="Noto Sans SC"/>
+                <a:ea typeface="Noto Sans SC Static"/>
               </a:rPr>
               <a:t>OFDM接收、CNN解码、LDPC译码</a:t>
             </a:r>
@@ -21207,7 +21335,7 @@
                   <a:srgbClr val="1F2933"/>
                 </a:solidFill>
                 <a:latin typeface="Calibri"/>
-                <a:ea typeface="Noto Sans SC"/>
+                <a:ea typeface="Noto Sans SC Static"/>
               </a:rPr>
               <a:t>触摸屏</a:t>
             </a:r>
@@ -21265,7 +21393,7 @@
                   <a:srgbClr val="1F2933"/>
                 </a:solidFill>
                 <a:latin typeface="Calibri"/>
-                <a:ea typeface="Noto Sans SC"/>
+                <a:ea typeface="Noto Sans SC Static"/>
               </a:rPr>
               <a:t>手机</a:t>
             </a:r>
@@ -21337,7 +21465,7 @@
                   <a:srgbClr val="52606D"/>
                 </a:solidFill>
                 <a:latin typeface="Calibri"/>
-                <a:ea typeface="Noto Sans SC"/>
+                <a:ea typeface="Noto Sans SC Static"/>
               </a:rPr>
               <a:t>DP</a:t>
             </a:r>
@@ -21411,7 +21539,7 @@
                   <a:srgbClr val="52606D"/>
                 </a:solidFill>
                 <a:latin typeface="Calibri"/>
-                <a:ea typeface="Noto Sans SC"/>
+                <a:ea typeface="Noto Sans SC Static"/>
               </a:rPr>
               <a:t>Wi-Fi</a:t>
             </a:r>
@@ -21469,7 +21597,7 @@
                   <a:srgbClr val="1F2933"/>
                 </a:solidFill>
                 <a:latin typeface="Calibri"/>
-                <a:ea typeface="Noto Sans SC"/>
+                <a:ea typeface="Noto Sans SC Static"/>
               </a:rPr>
               <a:t>AD9361</a:t>
             </a:r>
@@ -21482,7 +21610,7 @@
                   <a:srgbClr val="52606D"/>
                 </a:solidFill>
                 <a:latin typeface="Calibri"/>
-                <a:ea typeface="Noto Sans SC"/>
+                <a:ea typeface="Noto Sans SC Static"/>
               </a:rPr>
               <a:t>射频子卡</a:t>
             </a:r>
@@ -21591,7 +21719,7 @@
                   <a:srgbClr val="52606D"/>
                 </a:solidFill>
                 <a:latin typeface="Calibri"/>
-                <a:ea typeface="Noto Sans SC"/>
+                <a:ea typeface="Noto Sans SC Static"/>
               </a:rPr>
               <a:t>AXI</a:t>
             </a:r>
@@ -21627,7 +21755,7 @@
                   <a:srgbClr val="52606D"/>
                 </a:solidFill>
                 <a:latin typeface="Calibri"/>
-                <a:ea typeface="Noto Sans SC"/>
+                <a:ea typeface="Noto Sans SC Static"/>
               </a:rPr>
               <a:t>FMC</a:t>
             </a:r>
@@ -21839,7 +21967,7 @@
                   <a:srgbClr val="C8602A"/>
                 </a:solidFill>
                 <a:latin typeface="Calibri"/>
-                <a:ea typeface="Noto Sans SC"/>
+                <a:ea typeface="Noto Sans SC Static"/>
               </a:rPr>
               <a:t>空口</a:t>
             </a:r>
@@ -21913,7 +22041,7 @@
                   <a:srgbClr val="52606D"/>
                 </a:solidFill>
                 <a:latin typeface="Calibri"/>
-                <a:ea typeface="Noto Sans SC"/>
+                <a:ea typeface="Noto Sans SC Static"/>
               </a:rPr>
               <a:t>以太网：TX预览图、控制</a:t>
             </a:r>
@@ -21949,7 +22077,7 @@
                   <a:srgbClr val="000000"/>
                 </a:solidFill>
                 <a:latin typeface="Calibri"/>
-                <a:ea typeface="Noto Sans SC"/>
+                <a:ea typeface="Noto Sans SC Static"/>
               </a:rPr>
               <a:t>系统组成</a:t>
             </a:r>
@@ -21985,7 +22113,7 @@
                   <a:srgbClr val="000000"/>
                 </a:solidFill>
                 <a:latin typeface="Calibri"/>
-                <a:ea typeface="Noto Sans SC"/>
+                <a:ea typeface="Noto Sans SC Static"/>
               </a:rPr>
               <a:t>关键创新点与解决的技术问题</a:t>
             </a:r>
@@ -22045,7 +22173,7 @@
                   <a:srgbClr val="000000"/>
                 </a:solidFill>
                 <a:latin typeface="Calibri"/>
-                <a:ea typeface="Noto Sans SC"/>
+                <a:ea typeface="Noto Sans SC Static"/>
               </a:rPr>
               <a:t>1. 流式CNN加速器：</a:t>
             </a:r>
@@ -22055,7 +22183,7 @@
                   <a:srgbClr val="000000"/>
                 </a:solidFill>
                 <a:latin typeface="Calibri"/>
-                <a:ea typeface="Noto Sans SC"/>
+                <a:ea typeface="Noto Sans SC Static"/>
               </a:rPr>
               <a:t>W8A12整数运算，64个卷积引擎组成层流水，运行于250 MHz；权重与激活全部片上存储，不访问DDR。</a:t>
             </a:r>
@@ -22072,7 +22200,7 @@
                   <a:srgbClr val="000000"/>
                 </a:solidFill>
                 <a:latin typeface="Calibri"/>
-                <a:ea typeface="Noto Sans SC"/>
+                <a:ea typeface="Noto Sans SC Static"/>
               </a:rPr>
               <a:t>2. 非对称浅层解码器：</a:t>
             </a:r>
@@ -22082,7 +22210,7 @@
                   <a:srgbClr val="000000"/>
                 </a:solidFill>
                 <a:latin typeface="Calibri"/>
-                <a:ea typeface="Noto Sans SC"/>
+                <a:ea typeface="Noto Sans SC Static"/>
               </a:rPr>
               <a:t>与编码器联合训练，乘加量降为原解码器的1/102；卷积工作量是已发表FPGA DeepJSCC实现（GLOBECOM 2025）的5.2倍，DSP和BRAM用量却更少。</a:t>
             </a:r>
@@ -22099,7 +22227,7 @@
                   <a:srgbClr val="000000"/>
                 </a:solidFill>
                 <a:latin typeface="Calibri"/>
-                <a:ea typeface="Noto Sans SC"/>
+                <a:ea typeface="Noto Sans SC Static"/>
               </a:rPr>
               <a:t>3. 软符号OFDM物理层：</a:t>
             </a:r>
@@ -22109,7 +22237,7 @@
                   <a:srgbClr val="000000"/>
                 </a:solidFill>
                 <a:latin typeface="Calibri"/>
-                <a:ea typeface="Noto Sans SC"/>
+                <a:ea typeface="Noto Sans SC Static"/>
               </a:rPr>
               <a:t>683个符号的长帧、PN扰码、二阶SFO/CPE跟踪；均衡后的I/Q不经判决直接送入解码器。</a:t>
             </a:r>
@@ -22145,7 +22273,7 @@
                   <a:srgbClr val="000000"/>
                 </a:solidFill>
                 <a:latin typeface="Calibri"/>
-                <a:ea typeface="Noto Sans SC"/>
+                <a:ea typeface="Noto Sans SC Static"/>
               </a:rPr>
               <a:t>4. 完整演示系统：</a:t>
             </a:r>
@@ -22155,7 +22283,7 @@
                   <a:srgbClr val="000000"/>
                 </a:solidFill>
                 <a:latin typeface="Calibri"/>
-                <a:ea typeface="Noto Sans SC"/>
+                <a:ea typeface="Noto Sans SC Static"/>
               </a:rPr>
               <a:t>从摄像头到触摸屏，实时显示PSNR和星座图，并用Mali-400 GPU绘制信道三维图。</a:t>
             </a:r>
@@ -22191,7 +22319,7 @@
                   <a:srgbClr val="000000"/>
                 </a:solidFill>
                 <a:latin typeface="Calibri"/>
-                <a:ea typeface="Noto Sans SC"/>
+                <a:ea typeface="Noto Sans SC Static"/>
               </a:rPr>
               <a:t>空口实测PSNR（DIV2K 0802，每幅图32,768个64QAM符号）</a:t>
             </a:r>
@@ -22245,7 +22373,7 @@
                   <a:srgbClr val="000000"/>
                 </a:solidFill>
                 <a:latin typeface="Calibri"/>
-                <a:ea typeface="Noto Sans SC"/>
+                <a:ea typeface="Noto Sans SC Static"/>
               </a:rPr>
               <a:t>DeepJSCC-Q在高SNR时比JPEG + LDPC高</a:t>
             </a:r>
@@ -22255,7 +22383,7 @@
                   <a:srgbClr val="000000"/>
                 </a:solidFill>
                 <a:latin typeface="Calibri"/>
-                <a:ea typeface="Noto Sans SC"/>
+                <a:ea typeface="Noto Sans SC Static"/>
               </a:rPr>
               <a:t>2.8 dB</a:t>
             </a:r>
@@ -22265,7 +22393,7 @@
                   <a:srgbClr val="000000"/>
                 </a:solidFill>
                 <a:latin typeface="Calibri"/>
-                <a:ea typeface="Noto Sans SC"/>
+                <a:ea typeface="Noto Sans SC Static"/>
               </a:rPr>
               <a:t>，SNR降到2.9 dB时仍有</a:t>
             </a:r>
@@ -22275,7 +22403,7 @@
                   <a:srgbClr val="000000"/>
                 </a:solidFill>
                 <a:latin typeface="Calibri"/>
-                <a:ea typeface="Noto Sans SC"/>
+                <a:ea typeface="Noto Sans SC Static"/>
               </a:rPr>
               <a:t>23.5 dB</a:t>
             </a:r>
@@ -22285,7 +22413,7 @@
                   <a:srgbClr val="000000"/>
                 </a:solidFill>
                 <a:latin typeface="Calibri"/>
-                <a:ea typeface="Noto Sans SC"/>
+                <a:ea typeface="Noto Sans SC Static"/>
               </a:rPr>
               <a:t>；基线在16～19.5 dB处断崖式失效。</a:t>
             </a:r>
@@ -22345,7 +22473,7 @@
                   <a:srgbClr val="000000"/>
                 </a:solidFill>
                 <a:latin typeface="Calibri"/>
-                <a:ea typeface="Noto Sans SC"/>
+                <a:ea typeface="Noto Sans SC Static"/>
               </a:rPr>
               <a:t>30 fps</a:t>
             </a:r>
@@ -22355,7 +22483,7 @@
                   <a:srgbClr val="000000"/>
                 </a:solidFill>
                 <a:latin typeface="Calibri"/>
-                <a:ea typeface="Noto Sans SC"/>
+                <a:ea typeface="Noto Sans SC Static"/>
               </a:rPr>
               <a:t>连续运行10分钟（18,020帧），PL内端到端时延</a:t>
             </a:r>
@@ -22365,7 +22493,7 @@
                   <a:srgbClr val="000000"/>
                 </a:solidFill>
                 <a:latin typeface="Calibri"/>
-                <a:ea typeface="Noto Sans SC"/>
+                <a:ea typeface="Noto Sans SC Static"/>
               </a:rPr>
               <a:t>67.5 ms</a:t>
             </a:r>
@@ -22411,7 +22539,7 @@
                             <a:srgbClr val="000000"/>
                           </a:solidFill>
                           <a:latin typeface="Calibri"/>
-                          <a:ea typeface="Noto Sans SC"/>
+                          <a:ea typeface="Noto Sans SC Static"/>
                         </a:rPr>
                         <a:t>工程</a:t>
                       </a:r>
@@ -22435,7 +22563,7 @@
                             <a:srgbClr val="000000"/>
                           </a:solidFill>
                           <a:latin typeface="Calibri"/>
-                          <a:ea typeface="Noto Sans SC"/>
+                          <a:ea typeface="Noto Sans SC Static"/>
                         </a:rPr>
                         <a:t>LUT</a:t>
                       </a:r>
@@ -22459,7 +22587,7 @@
                             <a:srgbClr val="000000"/>
                           </a:solidFill>
                           <a:latin typeface="Calibri"/>
-                          <a:ea typeface="Noto Sans SC"/>
+                          <a:ea typeface="Noto Sans SC Static"/>
                         </a:rPr>
                         <a:t>BRAM36</a:t>
                       </a:r>
@@ -22483,7 +22611,7 @@
                             <a:srgbClr val="000000"/>
                           </a:solidFill>
                           <a:latin typeface="Calibri"/>
-                          <a:ea typeface="Noto Sans SC"/>
+                          <a:ea typeface="Noto Sans SC Static"/>
                         </a:rPr>
                         <a:t>DSP</a:t>
                       </a:r>
@@ -22507,7 +22635,7 @@
                             <a:srgbClr val="000000"/>
                           </a:solidFill>
                           <a:latin typeface="Calibri"/>
-                          <a:ea typeface="Noto Sans SC"/>
+                          <a:ea typeface="Noto Sans SC Static"/>
                         </a:rPr>
                         <a:t>WNS (ns)</a:t>
                       </a:r>
@@ -22531,7 +22659,7 @@
                             <a:srgbClr val="000000"/>
                           </a:solidFill>
                           <a:latin typeface="Calibri"/>
-                          <a:ea typeface="Noto Sans SC"/>
+                          <a:ea typeface="Noto Sans SC Static"/>
                         </a:rPr>
                         <a:t>功耗*</a:t>
                       </a:r>
@@ -22557,7 +22685,7 @@
                             <a:srgbClr val="000000"/>
                           </a:solidFill>
                           <a:latin typeface="Calibri"/>
-                          <a:ea typeface="Noto Sans SC"/>
+                          <a:ea typeface="Noto Sans SC Static"/>
                         </a:rPr>
                         <a:t>TX</a:t>
                       </a:r>
@@ -22581,7 +22709,7 @@
                             <a:srgbClr val="000000"/>
                           </a:solidFill>
                           <a:latin typeface="Calibri"/>
-                          <a:ea typeface="Noto Sans SC"/>
+                          <a:ea typeface="Noto Sans SC Static"/>
                         </a:rPr>
                         <a:t>54,241</a:t>
                       </a:r>
@@ -22605,7 +22733,7 @@
                             <a:srgbClr val="000000"/>
                           </a:solidFill>
                           <a:latin typeface="Calibri"/>
-                          <a:ea typeface="Noto Sans SC"/>
+                          <a:ea typeface="Noto Sans SC Static"/>
                         </a:rPr>
                         <a:t>104.5</a:t>
                       </a:r>
@@ -22629,7 +22757,7 @@
                             <a:srgbClr val="000000"/>
                           </a:solidFill>
                           <a:latin typeface="Calibri"/>
-                          <a:ea typeface="Noto Sans SC"/>
+                          <a:ea typeface="Noto Sans SC Static"/>
                         </a:rPr>
                         <a:t>243</a:t>
                       </a:r>
@@ -22653,7 +22781,7 @@
                             <a:srgbClr val="000000"/>
                           </a:solidFill>
                           <a:latin typeface="Calibri"/>
-                          <a:ea typeface="Noto Sans SC"/>
+                          <a:ea typeface="Noto Sans SC Static"/>
                         </a:rPr>
                         <a:t>+0.082</a:t>
                       </a:r>
@@ -22677,7 +22805,7 @@
                             <a:srgbClr val="000000"/>
                           </a:solidFill>
                           <a:latin typeface="Calibri"/>
-                          <a:ea typeface="Noto Sans SC"/>
+                          <a:ea typeface="Noto Sans SC Static"/>
                         </a:rPr>
                         <a:t>3.07 W</a:t>
                       </a:r>
@@ -22703,7 +22831,7 @@
                             <a:srgbClr val="000000"/>
                           </a:solidFill>
                           <a:latin typeface="Calibri"/>
-                          <a:ea typeface="Noto Sans SC"/>
+                          <a:ea typeface="Noto Sans SC Static"/>
                         </a:rPr>
                         <a:t>RX</a:t>
                       </a:r>
@@ -22727,7 +22855,7 @@
                             <a:srgbClr val="000000"/>
                           </a:solidFill>
                           <a:latin typeface="Calibri"/>
-                          <a:ea typeface="Noto Sans SC"/>
+                          <a:ea typeface="Noto Sans SC Static"/>
                         </a:rPr>
                         <a:t>63,699</a:t>
                       </a:r>
@@ -22751,7 +22879,7 @@
                             <a:srgbClr val="000000"/>
                           </a:solidFill>
                           <a:latin typeface="Calibri"/>
-                          <a:ea typeface="Noto Sans SC"/>
+                          <a:ea typeface="Noto Sans SC Static"/>
                         </a:rPr>
                         <a:t>65.5</a:t>
                       </a:r>
@@ -22775,7 +22903,7 @@
                             <a:srgbClr val="000000"/>
                           </a:solidFill>
                           <a:latin typeface="Calibri"/>
-                          <a:ea typeface="Noto Sans SC"/>
+                          <a:ea typeface="Noto Sans SC Static"/>
                         </a:rPr>
                         <a:t>133</a:t>
                       </a:r>
@@ -22799,7 +22927,7 @@
                             <a:srgbClr val="000000"/>
                           </a:solidFill>
                           <a:latin typeface="Calibri"/>
-                          <a:ea typeface="Noto Sans SC"/>
+                          <a:ea typeface="Noto Sans SC Static"/>
                         </a:rPr>
                         <a:t>+0.307</a:t>
                       </a:r>
@@ -22823,7 +22951,7 @@
                             <a:srgbClr val="000000"/>
                           </a:solidFill>
                           <a:latin typeface="Calibri"/>
-                          <a:ea typeface="Noto Sans SC"/>
+                          <a:ea typeface="Noto Sans SC Static"/>
                         </a:rPr>
                         <a:t>3.44 W</a:t>
                       </a:r>
@@ -22869,7 +22997,7 @@
                   <a:srgbClr val="52606D"/>
                 </a:solidFill>
                 <a:latin typeface="Calibri"/>
-                <a:ea typeface="Noto Sans SC"/>
+                <a:ea typeface="Noto Sans SC Static"/>
               </a:rPr>
               <a:t>* 功耗为实测值，含PS、PL与DDR；资源为xczu5eg布局布线后结果</a:t>
             </a:r>

</xml_diff>

<commit_message>
Chinese poster: all three section headings in the Black weight
The heading test compared the text frame against the heading names,
but the vertical headings are one character per line, so their text
carried line breaks and did not match: they were set in the Bold
weight while 作品简介 used Black. The test now ignores whitespace, and
the heading runs drop the bold flag so no synthetic bold is drawn on
top of the Black weight.

Co-Authored-By: Claude Opus 5.5 <noreply@anthropic.com>
</commit_message>
<xml_diff>
--- a/report/poster/poster_amd_zh.pptx
+++ b/report/poster/poster_amd_zh.pptx
@@ -18508,7 +18508,7 @@
               </a:spcBef>
             </a:pPr>
             <a:r>
-              <a:rPr lang="zh-CN" sz="2200" b="1" dirty="0" altLang="en-US">
+              <a:rPr lang="zh-CN" sz="2200" b="0" dirty="0" altLang="en-US">
                 <a:solidFill>
                   <a:schemeClr val="bg1"/>
                 </a:solidFill>
@@ -19360,11 +19360,11 @@
               </a:spcBef>
             </a:pPr>
             <a:r>
-              <a:rPr sz="2200" b="1" lang="zh-CN" altLang="en-US">
+              <a:rPr sz="2200" b="0" lang="zh-CN" altLang="en-US">
                 <a:solidFill>
                   <a:srgbClr val="FFFFFF"/>
                 </a:solidFill>
-                <a:ea typeface="Noto Sans SC Static"/>
+                <a:ea typeface="Noto Sans SC Static Black"/>
               </a:rPr>
               <a:t>创</a:t>
             </a:r>
@@ -19379,11 +19379,11 @@
               </a:spcBef>
             </a:pPr>
             <a:r>
-              <a:rPr sz="2200" b="1" lang="zh-CN" altLang="en-US">
+              <a:rPr sz="2200" b="0" lang="zh-CN" altLang="en-US">
                 <a:solidFill>
                   <a:srgbClr val="FFFFFF"/>
                 </a:solidFill>
-                <a:ea typeface="Noto Sans SC Static"/>
+                <a:ea typeface="Noto Sans SC Static Black"/>
               </a:rPr>
               <a:t>新</a:t>
             </a:r>
@@ -19398,11 +19398,11 @@
               </a:spcBef>
             </a:pPr>
             <a:r>
-              <a:rPr sz="2200" b="1" lang="zh-CN" altLang="en-US">
+              <a:rPr sz="2200" b="0" lang="zh-CN" altLang="en-US">
                 <a:solidFill>
                   <a:srgbClr val="FFFFFF"/>
                 </a:solidFill>
-                <a:ea typeface="Noto Sans SC Static"/>
+                <a:ea typeface="Noto Sans SC Static Black"/>
               </a:rPr>
               <a:t>设</a:t>
             </a:r>
@@ -19417,11 +19417,11 @@
               </a:spcBef>
             </a:pPr>
             <a:r>
-              <a:rPr sz="2200" b="1" lang="zh-CN" altLang="en-US">
+              <a:rPr sz="2200" b="0" lang="zh-CN" altLang="en-US">
                 <a:solidFill>
                   <a:srgbClr val="FFFFFF"/>
                 </a:solidFill>
-                <a:ea typeface="Noto Sans SC Static"/>
+                <a:ea typeface="Noto Sans SC Static Black"/>
               </a:rPr>
               <a:t>计</a:t>
             </a:r>
@@ -19459,11 +19459,11 @@
               </a:spcBef>
             </a:pPr>
             <a:r>
-              <a:rPr sz="2200" b="1" lang="zh-CN" altLang="en-US">
+              <a:rPr sz="2200" b="0" lang="zh-CN" altLang="en-US">
                 <a:solidFill>
                   <a:srgbClr val="FFFFFF"/>
                 </a:solidFill>
-                <a:ea typeface="Noto Sans SC Static"/>
+                <a:ea typeface="Noto Sans SC Static Black"/>
               </a:rPr>
               <a:t>测</a:t>
             </a:r>
@@ -19478,11 +19478,11 @@
               </a:spcBef>
             </a:pPr>
             <a:r>
-              <a:rPr sz="2200" b="1" lang="zh-CN" altLang="en-US">
+              <a:rPr sz="2200" b="0" lang="zh-CN" altLang="en-US">
                 <a:solidFill>
                   <a:srgbClr val="FFFFFF"/>
                 </a:solidFill>
-                <a:ea typeface="Noto Sans SC Static"/>
+                <a:ea typeface="Noto Sans SC Static Black"/>
               </a:rPr>
               <a:t>试</a:t>
             </a:r>
@@ -19497,11 +19497,11 @@
               </a:spcBef>
             </a:pPr>
             <a:r>
-              <a:rPr sz="2200" b="1" lang="zh-CN" altLang="en-US">
+              <a:rPr sz="2200" b="0" lang="zh-CN" altLang="en-US">
                 <a:solidFill>
                   <a:srgbClr val="FFFFFF"/>
                 </a:solidFill>
-                <a:ea typeface="Noto Sans SC Static"/>
+                <a:ea typeface="Noto Sans SC Static Black"/>
               </a:rPr>
               <a:t>结</a:t>
             </a:r>
@@ -19516,11 +19516,11 @@
               </a:spcBef>
             </a:pPr>
             <a:r>
-              <a:rPr sz="2200" b="1" lang="zh-CN" altLang="en-US">
+              <a:rPr sz="2200" b="0" lang="zh-CN" altLang="en-US">
                 <a:solidFill>
                   <a:srgbClr val="FFFFFF"/>
                 </a:solidFill>
-                <a:ea typeface="Noto Sans SC Static"/>
+                <a:ea typeface="Noto Sans SC Static Black"/>
               </a:rPr>
               <a:t>果</a:t>
             </a:r>

</xml_diff>